<commit_message>
cal working! from 6 to 7 GHz
</commit_message>
<xml_diff>
--- a/JPA-CAL.pptx
+++ b/JPA-CAL.pptx
@@ -15,6 +15,11 @@
     <p:sldId id="263" r:id="rId9"/>
     <p:sldId id="264" r:id="rId10"/>
     <p:sldId id="265" r:id="rId11"/>
+    <p:sldId id="266" r:id="rId12"/>
+    <p:sldId id="268" r:id="rId13"/>
+    <p:sldId id="267" r:id="rId14"/>
+    <p:sldId id="269" r:id="rId15"/>
+    <p:sldId id="270" r:id="rId16"/>
   </p:sldIdLst>
   <p:sldSz cx="12192000" cy="6858000"/>
   <p:notesSz cx="6858000" cy="9144000"/>
@@ -113,6 +118,11 @@
       </a:defRPr>
     </a:lvl9pPr>
   </p:defaultTextStyle>
+  <p:extLst>
+    <p:ext uri="{EFAFB233-063F-42B5-8137-9DF3F51BA10A}">
+      <p15:sldGuideLst xmlns:p15="http://schemas.microsoft.com/office/powerpoint/2012/main"/>
+    </p:ext>
+  </p:extLst>
 </p:presentation>
 </file>
 
@@ -263,7 +273,7 @@
           <a:p>
             <a:fld id="{74EE53B9-33DB-40D1-B9DF-65A7E0D4D34C}" type="datetimeFigureOut">
               <a:rPr lang="en-US" smtClean="0"/>
-              <a:t>2/3/2026</a:t>
+              <a:t>2/5/2026</a:t>
             </a:fld>
             <a:endParaRPr lang="en-US"/>
           </a:p>
@@ -461,7 +471,7 @@
           <a:p>
             <a:fld id="{74EE53B9-33DB-40D1-B9DF-65A7E0D4D34C}" type="datetimeFigureOut">
               <a:rPr lang="en-US" smtClean="0"/>
-              <a:t>2/3/2026</a:t>
+              <a:t>2/5/2026</a:t>
             </a:fld>
             <a:endParaRPr lang="en-US"/>
           </a:p>
@@ -669,7 +679,7 @@
           <a:p>
             <a:fld id="{74EE53B9-33DB-40D1-B9DF-65A7E0D4D34C}" type="datetimeFigureOut">
               <a:rPr lang="en-US" smtClean="0"/>
-              <a:t>2/3/2026</a:t>
+              <a:t>2/5/2026</a:t>
             </a:fld>
             <a:endParaRPr lang="en-US"/>
           </a:p>
@@ -867,7 +877,7 @@
           <a:p>
             <a:fld id="{74EE53B9-33DB-40D1-B9DF-65A7E0D4D34C}" type="datetimeFigureOut">
               <a:rPr lang="en-US" smtClean="0"/>
-              <a:t>2/3/2026</a:t>
+              <a:t>2/5/2026</a:t>
             </a:fld>
             <a:endParaRPr lang="en-US"/>
           </a:p>
@@ -1142,7 +1152,7 @@
           <a:p>
             <a:fld id="{74EE53B9-33DB-40D1-B9DF-65A7E0D4D34C}" type="datetimeFigureOut">
               <a:rPr lang="en-US" smtClean="0"/>
-              <a:t>2/3/2026</a:t>
+              <a:t>2/5/2026</a:t>
             </a:fld>
             <a:endParaRPr lang="en-US"/>
           </a:p>
@@ -1407,7 +1417,7 @@
           <a:p>
             <a:fld id="{74EE53B9-33DB-40D1-B9DF-65A7E0D4D34C}" type="datetimeFigureOut">
               <a:rPr lang="en-US" smtClean="0"/>
-              <a:t>2/3/2026</a:t>
+              <a:t>2/5/2026</a:t>
             </a:fld>
             <a:endParaRPr lang="en-US"/>
           </a:p>
@@ -1819,7 +1829,7 @@
           <a:p>
             <a:fld id="{74EE53B9-33DB-40D1-B9DF-65A7E0D4D34C}" type="datetimeFigureOut">
               <a:rPr lang="en-US" smtClean="0"/>
-              <a:t>2/3/2026</a:t>
+              <a:t>2/5/2026</a:t>
             </a:fld>
             <a:endParaRPr lang="en-US"/>
           </a:p>
@@ -1960,7 +1970,7 @@
           <a:p>
             <a:fld id="{74EE53B9-33DB-40D1-B9DF-65A7E0D4D34C}" type="datetimeFigureOut">
               <a:rPr lang="en-US" smtClean="0"/>
-              <a:t>2/3/2026</a:t>
+              <a:t>2/5/2026</a:t>
             </a:fld>
             <a:endParaRPr lang="en-US"/>
           </a:p>
@@ -2073,7 +2083,7 @@
           <a:p>
             <a:fld id="{74EE53B9-33DB-40D1-B9DF-65A7E0D4D34C}" type="datetimeFigureOut">
               <a:rPr lang="en-US" smtClean="0"/>
-              <a:t>2/3/2026</a:t>
+              <a:t>2/5/2026</a:t>
             </a:fld>
             <a:endParaRPr lang="en-US"/>
           </a:p>
@@ -2384,7 +2394,7 @@
           <a:p>
             <a:fld id="{74EE53B9-33DB-40D1-B9DF-65A7E0D4D34C}" type="datetimeFigureOut">
               <a:rPr lang="en-US" smtClean="0"/>
-              <a:t>2/3/2026</a:t>
+              <a:t>2/5/2026</a:t>
             </a:fld>
             <a:endParaRPr lang="en-US"/>
           </a:p>
@@ -2672,7 +2682,7 @@
           <a:p>
             <a:fld id="{74EE53B9-33DB-40D1-B9DF-65A7E0D4D34C}" type="datetimeFigureOut">
               <a:rPr lang="en-US" smtClean="0"/>
-              <a:t>2/3/2026</a:t>
+              <a:t>2/5/2026</a:t>
             </a:fld>
             <a:endParaRPr lang="en-US"/>
           </a:p>
@@ -2913,7 +2923,7 @@
           <a:p>
             <a:fld id="{74EE53B9-33DB-40D1-B9DF-65A7E0D4D34C}" type="datetimeFigureOut">
               <a:rPr lang="en-US" smtClean="0"/>
-              <a:t>2/3/2026</a:t>
+              <a:t>2/5/2026</a:t>
             </a:fld>
             <a:endParaRPr lang="en-US"/>
           </a:p>
@@ -3437,14 +3447,994 @@
           <a:bodyPr/>
           <a:lstStyle/>
           <a:p>
-            <a:endParaRPr lang="en-US"/>
-          </a:p>
-        </p:txBody>
-      </p:sp>
+            <a:r>
+              <a:rPr lang="en-US" dirty="0"/>
+              <a:t>Compare Theory to Data for fixed values of parameters</a:t>
+            </a:r>
+          </a:p>
+        </p:txBody>
+      </p:sp>
+      <p:pic>
+        <p:nvPicPr>
+          <p:cNvPr id="5121" name="Picture 1">
+            <a:extLst>
+              <a:ext uri="{FF2B5EF4-FFF2-40B4-BE49-F238E27FC236}">
+                <a16:creationId xmlns:a16="http://schemas.microsoft.com/office/drawing/2014/main" id="{9D327E99-499F-2907-E4C3-44CE67058679}"/>
+              </a:ext>
+            </a:extLst>
+          </p:cNvPr>
+          <p:cNvPicPr>
+            <a:picLocks noChangeAspect="1" noChangeArrowheads="1"/>
+          </p:cNvPicPr>
+          <p:nvPr/>
+        </p:nvPicPr>
+        <p:blipFill>
+          <a:blip r:embed="rId2">
+            <a:extLst>
+              <a:ext uri="{28A0092B-C50C-407E-A947-70E740481C1C}">
+                <a14:useLocalDpi xmlns:a14="http://schemas.microsoft.com/office/drawing/2010/main" val="0"/>
+              </a:ext>
+            </a:extLst>
+          </a:blip>
+          <a:srcRect/>
+          <a:stretch>
+            <a:fillRect/>
+          </a:stretch>
+        </p:blipFill>
+        <p:spPr bwMode="auto">
+          <a:xfrm>
+            <a:off x="0" y="2217198"/>
+            <a:ext cx="4071067" cy="3152467"/>
+          </a:xfrm>
+          <a:prstGeom prst="rect">
+            <a:avLst/>
+          </a:prstGeom>
+          <a:noFill/>
+          <a:extLst>
+            <a:ext uri="{909E8E84-426E-40DD-AFC4-6F175D3DCCD1}">
+              <a14:hiddenFill xmlns:a14="http://schemas.microsoft.com/office/drawing/2010/main">
+                <a:solidFill>
+                  <a:srgbClr val="FFFFFF"/>
+                </a:solidFill>
+              </a14:hiddenFill>
+            </a:ext>
+          </a:extLst>
+        </p:spPr>
+      </p:pic>
+      <p:pic>
+        <p:nvPicPr>
+          <p:cNvPr id="5122" name="Picture 2">
+            <a:extLst>
+              <a:ext uri="{FF2B5EF4-FFF2-40B4-BE49-F238E27FC236}">
+                <a16:creationId xmlns:a16="http://schemas.microsoft.com/office/drawing/2014/main" id="{9A127B61-C0B9-7442-5EC2-C06F9E378731}"/>
+              </a:ext>
+            </a:extLst>
+          </p:cNvPr>
+          <p:cNvPicPr>
+            <a:picLocks noChangeAspect="1" noChangeArrowheads="1"/>
+          </p:cNvPicPr>
+          <p:nvPr/>
+        </p:nvPicPr>
+        <p:blipFill>
+          <a:blip r:embed="rId3">
+            <a:extLst>
+              <a:ext uri="{28A0092B-C50C-407E-A947-70E740481C1C}">
+                <a14:useLocalDpi xmlns:a14="http://schemas.microsoft.com/office/drawing/2010/main" val="0"/>
+              </a:ext>
+            </a:extLst>
+          </a:blip>
+          <a:srcRect/>
+          <a:stretch>
+            <a:fillRect/>
+          </a:stretch>
+        </p:blipFill>
+        <p:spPr bwMode="auto">
+          <a:xfrm>
+            <a:off x="4049868" y="2217197"/>
+            <a:ext cx="4071067" cy="3152467"/>
+          </a:xfrm>
+          <a:prstGeom prst="rect">
+            <a:avLst/>
+          </a:prstGeom>
+          <a:noFill/>
+          <a:extLst>
+            <a:ext uri="{909E8E84-426E-40DD-AFC4-6F175D3DCCD1}">
+              <a14:hiddenFill xmlns:a14="http://schemas.microsoft.com/office/drawing/2010/main">
+                <a:solidFill>
+                  <a:srgbClr val="FFFFFF"/>
+                </a:solidFill>
+              </a14:hiddenFill>
+            </a:ext>
+          </a:extLst>
+        </p:spPr>
+      </p:pic>
+      <p:pic>
+        <p:nvPicPr>
+          <p:cNvPr id="5123" name="Picture 3">
+            <a:extLst>
+              <a:ext uri="{FF2B5EF4-FFF2-40B4-BE49-F238E27FC236}">
+                <a16:creationId xmlns:a16="http://schemas.microsoft.com/office/drawing/2014/main" id="{6ED13095-6337-46BF-A35D-68994856F4D2}"/>
+              </a:ext>
+            </a:extLst>
+          </p:cNvPr>
+          <p:cNvPicPr>
+            <a:picLocks noChangeAspect="1" noChangeArrowheads="1"/>
+          </p:cNvPicPr>
+          <p:nvPr/>
+        </p:nvPicPr>
+        <p:blipFill>
+          <a:blip r:embed="rId4">
+            <a:extLst>
+              <a:ext uri="{28A0092B-C50C-407E-A947-70E740481C1C}">
+                <a14:useLocalDpi xmlns:a14="http://schemas.microsoft.com/office/drawing/2010/main" val="0"/>
+              </a:ext>
+            </a:extLst>
+          </a:blip>
+          <a:srcRect/>
+          <a:stretch>
+            <a:fillRect/>
+          </a:stretch>
+        </p:blipFill>
+        <p:spPr bwMode="auto">
+          <a:xfrm>
+            <a:off x="8099736" y="2217197"/>
+            <a:ext cx="4071067" cy="3152467"/>
+          </a:xfrm>
+          <a:prstGeom prst="rect">
+            <a:avLst/>
+          </a:prstGeom>
+          <a:noFill/>
+          <a:extLst>
+            <a:ext uri="{909E8E84-426E-40DD-AFC4-6F175D3DCCD1}">
+              <a14:hiddenFill xmlns:a14="http://schemas.microsoft.com/office/drawing/2010/main">
+                <a:solidFill>
+                  <a:srgbClr val="FFFFFF"/>
+                </a:solidFill>
+              </a14:hiddenFill>
+            </a:ext>
+          </a:extLst>
+        </p:spPr>
+      </p:pic>
     </p:spTree>
     <p:extLst>
       <p:ext uri="{BB962C8B-B14F-4D97-AF65-F5344CB8AC3E}">
         <p14:creationId xmlns:p14="http://schemas.microsoft.com/office/powerpoint/2010/main" val="4270711193"/>
+      </p:ext>
+    </p:extLst>
+  </p:cSld>
+  <p:clrMapOvr>
+    <a:masterClrMapping/>
+  </p:clrMapOvr>
+</p:sld>
+</file>
+
+<file path=ppt/slides/slide11.xml><?xml version="1.0" encoding="utf-8"?>
+<p:sld xmlns:a="http://schemas.openxmlformats.org/drawingml/2006/main" xmlns:r="http://schemas.openxmlformats.org/officeDocument/2006/relationships" xmlns:p="http://schemas.openxmlformats.org/presentationml/2006/main">
+  <p:cSld>
+    <p:spTree>
+      <p:nvGrpSpPr>
+        <p:cNvPr id="1" name=""/>
+        <p:cNvGrpSpPr/>
+        <p:nvPr/>
+      </p:nvGrpSpPr>
+      <p:grpSpPr>
+        <a:xfrm>
+          <a:off x="0" y="0"/>
+          <a:ext cx="0" cy="0"/>
+          <a:chOff x="0" y="0"/>
+          <a:chExt cx="0" cy="0"/>
+        </a:xfrm>
+      </p:grpSpPr>
+      <p:sp>
+        <p:nvSpPr>
+          <p:cNvPr id="2" name="Title 1">
+            <a:extLst>
+              <a:ext uri="{FF2B5EF4-FFF2-40B4-BE49-F238E27FC236}">
+                <a16:creationId xmlns:a16="http://schemas.microsoft.com/office/drawing/2014/main" id="{E7421A20-F497-7C7C-E5A7-5EC8D7164200}"/>
+              </a:ext>
+            </a:extLst>
+          </p:cNvPr>
+          <p:cNvSpPr>
+            <a:spLocks noGrp="1"/>
+          </p:cNvSpPr>
+          <p:nvPr>
+            <p:ph type="title"/>
+          </p:nvPr>
+        </p:nvSpPr>
+        <p:spPr/>
+        <p:txBody>
+          <a:bodyPr/>
+          <a:lstStyle/>
+          <a:p>
+            <a:r>
+              <a:rPr lang="en-US" dirty="0"/>
+              <a:t>Zoom In on Flux Bias and Frequency </a:t>
+            </a:r>
+          </a:p>
+        </p:txBody>
+      </p:sp>
+      <p:pic>
+        <p:nvPicPr>
+          <p:cNvPr id="6145" name="Picture 1">
+            <a:extLst>
+              <a:ext uri="{FF2B5EF4-FFF2-40B4-BE49-F238E27FC236}">
+                <a16:creationId xmlns:a16="http://schemas.microsoft.com/office/drawing/2014/main" id="{FBA92260-2EA3-7DF4-D759-5575740AD04D}"/>
+              </a:ext>
+            </a:extLst>
+          </p:cNvPr>
+          <p:cNvPicPr>
+            <a:picLocks noChangeAspect="1" noChangeArrowheads="1"/>
+          </p:cNvPicPr>
+          <p:nvPr/>
+        </p:nvPicPr>
+        <p:blipFill>
+          <a:blip r:embed="rId2">
+            <a:extLst>
+              <a:ext uri="{28A0092B-C50C-407E-A947-70E740481C1C}">
+                <a14:useLocalDpi xmlns:a14="http://schemas.microsoft.com/office/drawing/2010/main" val="0"/>
+              </a:ext>
+            </a:extLst>
+          </a:blip>
+          <a:srcRect/>
+          <a:stretch>
+            <a:fillRect/>
+          </a:stretch>
+        </p:blipFill>
+        <p:spPr bwMode="auto">
+          <a:xfrm>
+            <a:off x="103367" y="1876508"/>
+            <a:ext cx="5467350" cy="4314825"/>
+          </a:xfrm>
+          <a:prstGeom prst="rect">
+            <a:avLst/>
+          </a:prstGeom>
+          <a:noFill/>
+          <a:extLst>
+            <a:ext uri="{909E8E84-426E-40DD-AFC4-6F175D3DCCD1}">
+              <a14:hiddenFill xmlns:a14="http://schemas.microsoft.com/office/drawing/2010/main">
+                <a:solidFill>
+                  <a:srgbClr val="FFFFFF"/>
+                </a:solidFill>
+              </a14:hiddenFill>
+            </a:ext>
+          </a:extLst>
+        </p:spPr>
+      </p:pic>
+      <p:pic>
+        <p:nvPicPr>
+          <p:cNvPr id="6148" name="Picture 4">
+            <a:extLst>
+              <a:ext uri="{FF2B5EF4-FFF2-40B4-BE49-F238E27FC236}">
+                <a16:creationId xmlns:a16="http://schemas.microsoft.com/office/drawing/2014/main" id="{10226EDF-0B43-50AD-F0E0-71DFC682EAAA}"/>
+              </a:ext>
+            </a:extLst>
+          </p:cNvPr>
+          <p:cNvPicPr>
+            <a:picLocks noChangeAspect="1" noChangeArrowheads="1"/>
+          </p:cNvPicPr>
+          <p:nvPr/>
+        </p:nvPicPr>
+        <p:blipFill>
+          <a:blip r:embed="rId3">
+            <a:extLst>
+              <a:ext uri="{28A0092B-C50C-407E-A947-70E740481C1C}">
+                <a14:useLocalDpi xmlns:a14="http://schemas.microsoft.com/office/drawing/2010/main" val="0"/>
+              </a:ext>
+            </a:extLst>
+          </a:blip>
+          <a:srcRect/>
+          <a:stretch>
+            <a:fillRect/>
+          </a:stretch>
+        </p:blipFill>
+        <p:spPr bwMode="auto">
+          <a:xfrm>
+            <a:off x="5947576" y="1876508"/>
+            <a:ext cx="5619750" cy="4314825"/>
+          </a:xfrm>
+          <a:prstGeom prst="rect">
+            <a:avLst/>
+          </a:prstGeom>
+          <a:noFill/>
+          <a:extLst>
+            <a:ext uri="{909E8E84-426E-40DD-AFC4-6F175D3DCCD1}">
+              <a14:hiddenFill xmlns:a14="http://schemas.microsoft.com/office/drawing/2010/main">
+                <a:solidFill>
+                  <a:srgbClr val="FFFFFF"/>
+                </a:solidFill>
+              </a14:hiddenFill>
+            </a:ext>
+          </a:extLst>
+        </p:spPr>
+      </p:pic>
+    </p:spTree>
+    <p:extLst>
+      <p:ext uri="{BB962C8B-B14F-4D97-AF65-F5344CB8AC3E}">
+        <p14:creationId xmlns:p14="http://schemas.microsoft.com/office/powerpoint/2010/main" val="4140349570"/>
+      </p:ext>
+    </p:extLst>
+  </p:cSld>
+  <p:clrMapOvr>
+    <a:masterClrMapping/>
+  </p:clrMapOvr>
+</p:sld>
+</file>
+
+<file path=ppt/slides/slide12.xml><?xml version="1.0" encoding="utf-8"?>
+<p:sld xmlns:a="http://schemas.openxmlformats.org/drawingml/2006/main" xmlns:r="http://schemas.openxmlformats.org/officeDocument/2006/relationships" xmlns:p="http://schemas.openxmlformats.org/presentationml/2006/main">
+  <p:cSld>
+    <p:spTree>
+      <p:nvGrpSpPr>
+        <p:cNvPr id="1" name=""/>
+        <p:cNvGrpSpPr/>
+        <p:nvPr/>
+      </p:nvGrpSpPr>
+      <p:grpSpPr>
+        <a:xfrm>
+          <a:off x="0" y="0"/>
+          <a:ext cx="0" cy="0"/>
+          <a:chOff x="0" y="0"/>
+          <a:chExt cx="0" cy="0"/>
+        </a:xfrm>
+      </p:grpSpPr>
+      <p:sp>
+        <p:nvSpPr>
+          <p:cNvPr id="2" name="Title 1">
+            <a:extLst>
+              <a:ext uri="{FF2B5EF4-FFF2-40B4-BE49-F238E27FC236}">
+                <a16:creationId xmlns:a16="http://schemas.microsoft.com/office/drawing/2014/main" id="{6F7A3C6F-BD88-5D17-D02D-A4F0596D9284}"/>
+              </a:ext>
+            </a:extLst>
+          </p:cNvPr>
+          <p:cNvSpPr>
+            <a:spLocks noGrp="1"/>
+          </p:cNvSpPr>
+          <p:nvPr>
+            <p:ph type="title"/>
+          </p:nvPr>
+        </p:nvSpPr>
+        <p:spPr/>
+        <p:txBody>
+          <a:bodyPr/>
+          <a:lstStyle/>
+          <a:p>
+            <a:r>
+              <a:rPr lang="en-US" dirty="0"/>
+              <a:t>Amplitude</a:t>
+            </a:r>
+          </a:p>
+        </p:txBody>
+      </p:sp>
+      <p:pic>
+        <p:nvPicPr>
+          <p:cNvPr id="8194" name="Picture 2">
+            <a:extLst>
+              <a:ext uri="{FF2B5EF4-FFF2-40B4-BE49-F238E27FC236}">
+                <a16:creationId xmlns:a16="http://schemas.microsoft.com/office/drawing/2014/main" id="{336BFEFF-34E5-1915-C7A5-31C748FC9E34}"/>
+              </a:ext>
+            </a:extLst>
+          </p:cNvPr>
+          <p:cNvPicPr>
+            <a:picLocks noChangeAspect="1" noChangeArrowheads="1"/>
+          </p:cNvPicPr>
+          <p:nvPr/>
+        </p:nvPicPr>
+        <p:blipFill>
+          <a:blip r:embed="rId2">
+            <a:extLst>
+              <a:ext uri="{28A0092B-C50C-407E-A947-70E740481C1C}">
+                <a14:useLocalDpi xmlns:a14="http://schemas.microsoft.com/office/drawing/2010/main" val="0"/>
+              </a:ext>
+            </a:extLst>
+          </a:blip>
+          <a:srcRect/>
+          <a:stretch>
+            <a:fillRect/>
+          </a:stretch>
+        </p:blipFill>
+        <p:spPr bwMode="auto">
+          <a:xfrm>
+            <a:off x="2798859" y="2115046"/>
+            <a:ext cx="5572125" cy="4114800"/>
+          </a:xfrm>
+          <a:prstGeom prst="rect">
+            <a:avLst/>
+          </a:prstGeom>
+          <a:noFill/>
+          <a:extLst>
+            <a:ext uri="{909E8E84-426E-40DD-AFC4-6F175D3DCCD1}">
+              <a14:hiddenFill xmlns:a14="http://schemas.microsoft.com/office/drawing/2010/main">
+                <a:solidFill>
+                  <a:srgbClr val="FFFFFF"/>
+                </a:solidFill>
+              </a14:hiddenFill>
+            </a:ext>
+          </a:extLst>
+        </p:spPr>
+      </p:pic>
+    </p:spTree>
+    <p:extLst>
+      <p:ext uri="{BB962C8B-B14F-4D97-AF65-F5344CB8AC3E}">
+        <p14:creationId xmlns:p14="http://schemas.microsoft.com/office/powerpoint/2010/main" val="2816371056"/>
+      </p:ext>
+    </p:extLst>
+  </p:cSld>
+  <p:clrMapOvr>
+    <a:masterClrMapping/>
+  </p:clrMapOvr>
+</p:sld>
+</file>
+
+<file path=ppt/slides/slide13.xml><?xml version="1.0" encoding="utf-8"?>
+<p:sld xmlns:a="http://schemas.openxmlformats.org/drawingml/2006/main" xmlns:r="http://schemas.openxmlformats.org/officeDocument/2006/relationships" xmlns:p="http://schemas.openxmlformats.org/presentationml/2006/main">
+  <p:cSld>
+    <p:spTree>
+      <p:nvGrpSpPr>
+        <p:cNvPr id="1" name=""/>
+        <p:cNvGrpSpPr/>
+        <p:nvPr/>
+      </p:nvGrpSpPr>
+      <p:grpSpPr>
+        <a:xfrm>
+          <a:off x="0" y="0"/>
+          <a:ext cx="0" cy="0"/>
+          <a:chOff x="0" y="0"/>
+          <a:chExt cx="0" cy="0"/>
+        </a:xfrm>
+      </p:grpSpPr>
+      <p:sp>
+        <p:nvSpPr>
+          <p:cNvPr id="2" name="Title 1">
+            <a:extLst>
+              <a:ext uri="{FF2B5EF4-FFF2-40B4-BE49-F238E27FC236}">
+                <a16:creationId xmlns:a16="http://schemas.microsoft.com/office/drawing/2014/main" id="{D431F7FC-F083-B00B-460F-8FC6A5A79D61}"/>
+              </a:ext>
+            </a:extLst>
+          </p:cNvPr>
+          <p:cNvSpPr>
+            <a:spLocks noGrp="1"/>
+          </p:cNvSpPr>
+          <p:nvPr>
+            <p:ph type="title"/>
+          </p:nvPr>
+        </p:nvSpPr>
+        <p:spPr/>
+        <p:txBody>
+          <a:bodyPr/>
+          <a:lstStyle/>
+          <a:p>
+            <a:r>
+              <a:rPr lang="en-US" dirty="0"/>
+              <a:t>Calculated standards curves</a:t>
+            </a:r>
+          </a:p>
+        </p:txBody>
+      </p:sp>
+      <p:pic>
+        <p:nvPicPr>
+          <p:cNvPr id="7169" name="Picture 1">
+            <a:extLst>
+              <a:ext uri="{FF2B5EF4-FFF2-40B4-BE49-F238E27FC236}">
+                <a16:creationId xmlns:a16="http://schemas.microsoft.com/office/drawing/2014/main" id="{34A7E707-687C-AC88-BE65-BA8AFDE2374C}"/>
+              </a:ext>
+            </a:extLst>
+          </p:cNvPr>
+          <p:cNvPicPr>
+            <a:picLocks noChangeAspect="1" noChangeArrowheads="1"/>
+          </p:cNvPicPr>
+          <p:nvPr/>
+        </p:nvPicPr>
+        <p:blipFill>
+          <a:blip r:embed="rId2">
+            <a:extLst>
+              <a:ext uri="{28A0092B-C50C-407E-A947-70E740481C1C}">
+                <a14:useLocalDpi xmlns:a14="http://schemas.microsoft.com/office/drawing/2010/main" val="0"/>
+              </a:ext>
+            </a:extLst>
+          </a:blip>
+          <a:srcRect/>
+          <a:stretch>
+            <a:fillRect/>
+          </a:stretch>
+        </p:blipFill>
+        <p:spPr bwMode="auto">
+          <a:xfrm>
+            <a:off x="2679589" y="1828800"/>
+            <a:ext cx="5619750" cy="4314825"/>
+          </a:xfrm>
+          <a:prstGeom prst="rect">
+            <a:avLst/>
+          </a:prstGeom>
+          <a:noFill/>
+          <a:extLst>
+            <a:ext uri="{909E8E84-426E-40DD-AFC4-6F175D3DCCD1}">
+              <a14:hiddenFill xmlns:a14="http://schemas.microsoft.com/office/drawing/2010/main">
+                <a:solidFill>
+                  <a:srgbClr val="FFFFFF"/>
+                </a:solidFill>
+              </a14:hiddenFill>
+            </a:ext>
+          </a:extLst>
+        </p:spPr>
+      </p:pic>
+    </p:spTree>
+    <p:extLst>
+      <p:ext uri="{BB962C8B-B14F-4D97-AF65-F5344CB8AC3E}">
+        <p14:creationId xmlns:p14="http://schemas.microsoft.com/office/powerpoint/2010/main" val="3603165702"/>
+      </p:ext>
+    </p:extLst>
+  </p:cSld>
+  <p:clrMapOvr>
+    <a:masterClrMapping/>
+  </p:clrMapOvr>
+</p:sld>
+</file>
+
+<file path=ppt/slides/slide14.xml><?xml version="1.0" encoding="utf-8"?>
+<p:sld xmlns:a="http://schemas.openxmlformats.org/drawingml/2006/main" xmlns:r="http://schemas.openxmlformats.org/officeDocument/2006/relationships" xmlns:p="http://schemas.openxmlformats.org/presentationml/2006/main">
+  <p:cSld>
+    <p:spTree>
+      <p:nvGrpSpPr>
+        <p:cNvPr id="1" name=""/>
+        <p:cNvGrpSpPr/>
+        <p:nvPr/>
+      </p:nvGrpSpPr>
+      <p:grpSpPr>
+        <a:xfrm>
+          <a:off x="0" y="0"/>
+          <a:ext cx="0" cy="0"/>
+          <a:chOff x="0" y="0"/>
+          <a:chExt cx="0" cy="0"/>
+        </a:xfrm>
+      </p:grpSpPr>
+      <p:sp>
+        <p:nvSpPr>
+          <p:cNvPr id="2" name="Title 1">
+            <a:extLst>
+              <a:ext uri="{FF2B5EF4-FFF2-40B4-BE49-F238E27FC236}">
+                <a16:creationId xmlns:a16="http://schemas.microsoft.com/office/drawing/2014/main" id="{A9257055-97EF-6324-2A90-E4BEF2D9445A}"/>
+              </a:ext>
+            </a:extLst>
+          </p:cNvPr>
+          <p:cNvSpPr>
+            <a:spLocks noGrp="1"/>
+          </p:cNvSpPr>
+          <p:nvPr>
+            <p:ph type="title"/>
+          </p:nvPr>
+        </p:nvSpPr>
+        <p:spPr/>
+        <p:txBody>
+          <a:bodyPr/>
+          <a:lstStyle/>
+          <a:p>
+            <a:r>
+              <a:rPr lang="en-US" dirty="0"/>
+              <a:t>South-West-And-North Calibration</a:t>
+            </a:r>
+          </a:p>
+        </p:txBody>
+      </p:sp>
+      <p:pic>
+        <p:nvPicPr>
+          <p:cNvPr id="9220" name="Picture 4">
+            <a:extLst>
+              <a:ext uri="{FF2B5EF4-FFF2-40B4-BE49-F238E27FC236}">
+                <a16:creationId xmlns:a16="http://schemas.microsoft.com/office/drawing/2014/main" id="{30AAC7B2-6474-FFA3-82B6-6988C2374978}"/>
+              </a:ext>
+            </a:extLst>
+          </p:cNvPr>
+          <p:cNvPicPr>
+            <a:picLocks noChangeAspect="1" noChangeArrowheads="1"/>
+          </p:cNvPicPr>
+          <p:nvPr/>
+        </p:nvPicPr>
+        <p:blipFill>
+          <a:blip r:embed="rId2">
+            <a:extLst>
+              <a:ext uri="{28A0092B-C50C-407E-A947-70E740481C1C}">
+                <a14:useLocalDpi xmlns:a14="http://schemas.microsoft.com/office/drawing/2010/main" val="0"/>
+              </a:ext>
+            </a:extLst>
+          </a:blip>
+          <a:srcRect/>
+          <a:stretch>
+            <a:fillRect/>
+          </a:stretch>
+        </p:blipFill>
+        <p:spPr bwMode="auto">
+          <a:xfrm>
+            <a:off x="6431282" y="1500187"/>
+            <a:ext cx="5219700" cy="5191125"/>
+          </a:xfrm>
+          <a:prstGeom prst="rect">
+            <a:avLst/>
+          </a:prstGeom>
+          <a:noFill/>
+          <a:extLst>
+            <a:ext uri="{909E8E84-426E-40DD-AFC4-6F175D3DCCD1}">
+              <a14:hiddenFill xmlns:a14="http://schemas.microsoft.com/office/drawing/2010/main">
+                <a:solidFill>
+                  <a:srgbClr val="FFFFFF"/>
+                </a:solidFill>
+              </a14:hiddenFill>
+            </a:ext>
+          </a:extLst>
+        </p:spPr>
+      </p:pic>
+      <p:pic>
+        <p:nvPicPr>
+          <p:cNvPr id="9221" name="Picture 5">
+            <a:extLst>
+              <a:ext uri="{FF2B5EF4-FFF2-40B4-BE49-F238E27FC236}">
+                <a16:creationId xmlns:a16="http://schemas.microsoft.com/office/drawing/2014/main" id="{634D5128-4742-DCFD-6A8D-E1D0969E02BE}"/>
+              </a:ext>
+            </a:extLst>
+          </p:cNvPr>
+          <p:cNvPicPr>
+            <a:picLocks noChangeAspect="1" noChangeArrowheads="1"/>
+          </p:cNvPicPr>
+          <p:nvPr/>
+        </p:nvPicPr>
+        <p:blipFill>
+          <a:blip r:embed="rId3">
+            <a:extLst>
+              <a:ext uri="{28A0092B-C50C-407E-A947-70E740481C1C}">
+                <a14:useLocalDpi xmlns:a14="http://schemas.microsoft.com/office/drawing/2010/main" val="0"/>
+              </a:ext>
+            </a:extLst>
+          </a:blip>
+          <a:srcRect/>
+          <a:stretch>
+            <a:fillRect/>
+          </a:stretch>
+        </p:blipFill>
+        <p:spPr bwMode="auto">
+          <a:xfrm>
+            <a:off x="667909" y="1500187"/>
+            <a:ext cx="5219700" cy="5191125"/>
+          </a:xfrm>
+          <a:prstGeom prst="rect">
+            <a:avLst/>
+          </a:prstGeom>
+          <a:noFill/>
+          <a:extLst>
+            <a:ext uri="{909E8E84-426E-40DD-AFC4-6F175D3DCCD1}">
+              <a14:hiddenFill xmlns:a14="http://schemas.microsoft.com/office/drawing/2010/main">
+                <a:solidFill>
+                  <a:srgbClr val="FFFFFF"/>
+                </a:solidFill>
+              </a14:hiddenFill>
+            </a:ext>
+          </a:extLst>
+        </p:spPr>
+      </p:pic>
+      <p:sp>
+        <p:nvSpPr>
+          <p:cNvPr id="4" name="TextBox 3">
+            <a:extLst>
+              <a:ext uri="{FF2B5EF4-FFF2-40B4-BE49-F238E27FC236}">
+                <a16:creationId xmlns:a16="http://schemas.microsoft.com/office/drawing/2014/main" id="{F30B41C2-D1E4-B5CE-B624-6EA09E108613}"/>
+              </a:ext>
+            </a:extLst>
+          </p:cNvPr>
+          <p:cNvSpPr txBox="1"/>
+          <p:nvPr/>
+        </p:nvSpPr>
+        <p:spPr>
+          <a:xfrm>
+            <a:off x="3096701" y="2258168"/>
+            <a:ext cx="1101588" cy="369332"/>
+          </a:xfrm>
+          <a:prstGeom prst="rect">
+            <a:avLst/>
+          </a:prstGeom>
+          <a:noFill/>
+        </p:spPr>
+        <p:txBody>
+          <a:bodyPr wrap="square" rtlCol="0">
+            <a:spAutoFit/>
+          </a:bodyPr>
+          <a:lstStyle/>
+          <a:p>
+            <a:r>
+              <a:rPr lang="en-US" dirty="0">
+                <a:solidFill>
+                  <a:srgbClr val="0000FF"/>
+                </a:solidFill>
+              </a:rPr>
+              <a:t>NORTH</a:t>
+            </a:r>
+          </a:p>
+        </p:txBody>
+      </p:sp>
+      <p:sp>
+        <p:nvSpPr>
+          <p:cNvPr id="5" name="TextBox 4">
+            <a:extLst>
+              <a:ext uri="{FF2B5EF4-FFF2-40B4-BE49-F238E27FC236}">
+                <a16:creationId xmlns:a16="http://schemas.microsoft.com/office/drawing/2014/main" id="{0B4DC7A2-FF4D-54CF-CF7E-2E4331B85C59}"/>
+              </a:ext>
+            </a:extLst>
+          </p:cNvPr>
+          <p:cNvSpPr txBox="1"/>
+          <p:nvPr/>
+        </p:nvSpPr>
+        <p:spPr>
+          <a:xfrm>
+            <a:off x="8964764" y="2297927"/>
+            <a:ext cx="1101588" cy="369332"/>
+          </a:xfrm>
+          <a:prstGeom prst="rect">
+            <a:avLst/>
+          </a:prstGeom>
+          <a:noFill/>
+        </p:spPr>
+        <p:txBody>
+          <a:bodyPr wrap="square" rtlCol="0">
+            <a:spAutoFit/>
+          </a:bodyPr>
+          <a:lstStyle/>
+          <a:p>
+            <a:r>
+              <a:rPr lang="en-US" dirty="0">
+                <a:solidFill>
+                  <a:srgbClr val="0000FF"/>
+                </a:solidFill>
+              </a:rPr>
+              <a:t>NORTH</a:t>
+            </a:r>
+          </a:p>
+        </p:txBody>
+      </p:sp>
+      <p:sp>
+        <p:nvSpPr>
+          <p:cNvPr id="6" name="TextBox 5">
+            <a:extLst>
+              <a:ext uri="{FF2B5EF4-FFF2-40B4-BE49-F238E27FC236}">
+                <a16:creationId xmlns:a16="http://schemas.microsoft.com/office/drawing/2014/main" id="{5E00C3B0-E093-AD10-30B4-CB50CC4944EC}"/>
+              </a:ext>
+            </a:extLst>
+          </p:cNvPr>
+          <p:cNvSpPr txBox="1"/>
+          <p:nvPr/>
+        </p:nvSpPr>
+        <p:spPr>
+          <a:xfrm>
+            <a:off x="3096701" y="5192619"/>
+            <a:ext cx="1101588" cy="369332"/>
+          </a:xfrm>
+          <a:prstGeom prst="rect">
+            <a:avLst/>
+          </a:prstGeom>
+          <a:noFill/>
+        </p:spPr>
+        <p:txBody>
+          <a:bodyPr wrap="square" rtlCol="0">
+            <a:spAutoFit/>
+          </a:bodyPr>
+          <a:lstStyle/>
+          <a:p>
+            <a:r>
+              <a:rPr lang="en-US" dirty="0">
+                <a:solidFill>
+                  <a:srgbClr val="FF0000"/>
+                </a:solidFill>
+              </a:rPr>
+              <a:t>SOUTH</a:t>
+            </a:r>
+          </a:p>
+        </p:txBody>
+      </p:sp>
+      <p:sp>
+        <p:nvSpPr>
+          <p:cNvPr id="7" name="TextBox 6">
+            <a:extLst>
+              <a:ext uri="{FF2B5EF4-FFF2-40B4-BE49-F238E27FC236}">
+                <a16:creationId xmlns:a16="http://schemas.microsoft.com/office/drawing/2014/main" id="{82217ECF-74A7-0274-0500-E423E413D5AA}"/>
+              </a:ext>
+            </a:extLst>
+          </p:cNvPr>
+          <p:cNvSpPr txBox="1"/>
+          <p:nvPr/>
+        </p:nvSpPr>
+        <p:spPr>
+          <a:xfrm>
+            <a:off x="8964764" y="5192619"/>
+            <a:ext cx="1101588" cy="369332"/>
+          </a:xfrm>
+          <a:prstGeom prst="rect">
+            <a:avLst/>
+          </a:prstGeom>
+          <a:noFill/>
+        </p:spPr>
+        <p:txBody>
+          <a:bodyPr wrap="square" rtlCol="0">
+            <a:spAutoFit/>
+          </a:bodyPr>
+          <a:lstStyle/>
+          <a:p>
+            <a:r>
+              <a:rPr lang="en-US" dirty="0">
+                <a:solidFill>
+                  <a:srgbClr val="FF0000"/>
+                </a:solidFill>
+              </a:rPr>
+              <a:t>SOUTH</a:t>
+            </a:r>
+          </a:p>
+        </p:txBody>
+      </p:sp>
+      <p:sp>
+        <p:nvSpPr>
+          <p:cNvPr id="8" name="TextBox 7">
+            <a:extLst>
+              <a:ext uri="{FF2B5EF4-FFF2-40B4-BE49-F238E27FC236}">
+                <a16:creationId xmlns:a16="http://schemas.microsoft.com/office/drawing/2014/main" id="{614C75DB-CD13-F64B-90E0-738FEEBA6F33}"/>
+              </a:ext>
+            </a:extLst>
+          </p:cNvPr>
+          <p:cNvSpPr txBox="1"/>
+          <p:nvPr/>
+        </p:nvSpPr>
+        <p:spPr>
+          <a:xfrm>
+            <a:off x="1792687" y="3821668"/>
+            <a:ext cx="1101588" cy="369332"/>
+          </a:xfrm>
+          <a:prstGeom prst="rect">
+            <a:avLst/>
+          </a:prstGeom>
+          <a:noFill/>
+        </p:spPr>
+        <p:txBody>
+          <a:bodyPr wrap="square" rtlCol="0">
+            <a:spAutoFit/>
+          </a:bodyPr>
+          <a:lstStyle/>
+          <a:p>
+            <a:r>
+              <a:rPr lang="en-US" dirty="0">
+                <a:solidFill>
+                  <a:schemeClr val="accent3"/>
+                </a:solidFill>
+              </a:rPr>
+              <a:t>WEST</a:t>
+            </a:r>
+          </a:p>
+        </p:txBody>
+      </p:sp>
+      <p:sp>
+        <p:nvSpPr>
+          <p:cNvPr id="9" name="TextBox 8">
+            <a:extLst>
+              <a:ext uri="{FF2B5EF4-FFF2-40B4-BE49-F238E27FC236}">
+                <a16:creationId xmlns:a16="http://schemas.microsoft.com/office/drawing/2014/main" id="{967E5825-A601-1937-F3EE-E48D936D5994}"/>
+              </a:ext>
+            </a:extLst>
+          </p:cNvPr>
+          <p:cNvSpPr txBox="1"/>
+          <p:nvPr/>
+        </p:nvSpPr>
+        <p:spPr>
+          <a:xfrm>
+            <a:off x="7795922" y="3830282"/>
+            <a:ext cx="1101588" cy="369332"/>
+          </a:xfrm>
+          <a:prstGeom prst="rect">
+            <a:avLst/>
+          </a:prstGeom>
+          <a:noFill/>
+        </p:spPr>
+        <p:txBody>
+          <a:bodyPr wrap="square" rtlCol="0">
+            <a:spAutoFit/>
+          </a:bodyPr>
+          <a:lstStyle/>
+          <a:p>
+            <a:r>
+              <a:rPr lang="en-US" dirty="0">
+                <a:solidFill>
+                  <a:schemeClr val="accent3"/>
+                </a:solidFill>
+              </a:rPr>
+              <a:t>WEST</a:t>
+            </a:r>
+          </a:p>
+        </p:txBody>
+      </p:sp>
+    </p:spTree>
+    <p:extLst>
+      <p:ext uri="{BB962C8B-B14F-4D97-AF65-F5344CB8AC3E}">
+        <p14:creationId xmlns:p14="http://schemas.microsoft.com/office/powerpoint/2010/main" val="684460139"/>
+      </p:ext>
+    </p:extLst>
+  </p:cSld>
+  <p:clrMapOvr>
+    <a:masterClrMapping/>
+  </p:clrMapOvr>
+</p:sld>
+</file>
+
+<file path=ppt/slides/slide15.xml><?xml version="1.0" encoding="utf-8"?>
+<p:sld xmlns:a="http://schemas.openxmlformats.org/drawingml/2006/main" xmlns:r="http://schemas.openxmlformats.org/officeDocument/2006/relationships" xmlns:p="http://schemas.openxmlformats.org/presentationml/2006/main">
+  <p:cSld>
+    <p:spTree>
+      <p:nvGrpSpPr>
+        <p:cNvPr id="1" name=""/>
+        <p:cNvGrpSpPr/>
+        <p:nvPr/>
+      </p:nvGrpSpPr>
+      <p:grpSpPr>
+        <a:xfrm>
+          <a:off x="0" y="0"/>
+          <a:ext cx="0" cy="0"/>
+          <a:chOff x="0" y="0"/>
+          <a:chExt cx="0" cy="0"/>
+        </a:xfrm>
+      </p:grpSpPr>
+      <p:sp>
+        <p:nvSpPr>
+          <p:cNvPr id="2" name="Title 1">
+            <a:extLst>
+              <a:ext uri="{FF2B5EF4-FFF2-40B4-BE49-F238E27FC236}">
+                <a16:creationId xmlns:a16="http://schemas.microsoft.com/office/drawing/2014/main" id="{25A197F0-1FDD-6D10-6BBD-D568A658DA15}"/>
+              </a:ext>
+            </a:extLst>
+          </p:cNvPr>
+          <p:cNvSpPr>
+            <a:spLocks noGrp="1"/>
+          </p:cNvSpPr>
+          <p:nvPr>
+            <p:ph type="title"/>
+          </p:nvPr>
+        </p:nvSpPr>
+        <p:spPr/>
+        <p:txBody>
+          <a:bodyPr/>
+          <a:lstStyle/>
+          <a:p>
+            <a:r>
+              <a:rPr lang="en-US" dirty="0"/>
+              <a:t>SWaN Cal In Scikit-RF</a:t>
+            </a:r>
+          </a:p>
+        </p:txBody>
+      </p:sp>
+      <p:pic>
+        <p:nvPicPr>
+          <p:cNvPr id="5" name="Picture 4">
+            <a:extLst>
+              <a:ext uri="{FF2B5EF4-FFF2-40B4-BE49-F238E27FC236}">
+                <a16:creationId xmlns:a16="http://schemas.microsoft.com/office/drawing/2014/main" id="{940077C7-E95C-7452-D918-57A646F84EAB}"/>
+              </a:ext>
+            </a:extLst>
+          </p:cNvPr>
+          <p:cNvPicPr>
+            <a:picLocks noChangeAspect="1"/>
+          </p:cNvPicPr>
+          <p:nvPr/>
+        </p:nvPicPr>
+        <p:blipFill>
+          <a:blip r:embed="rId2"/>
+          <a:stretch>
+            <a:fillRect/>
+          </a:stretch>
+        </p:blipFill>
+        <p:spPr>
+          <a:xfrm>
+            <a:off x="2771196" y="1910711"/>
+            <a:ext cx="6506483" cy="4582164"/>
+          </a:xfrm>
+          <a:prstGeom prst="rect">
+            <a:avLst/>
+          </a:prstGeom>
+        </p:spPr>
+      </p:pic>
+    </p:spTree>
+    <p:extLst>
+      <p:ext uri="{BB962C8B-B14F-4D97-AF65-F5344CB8AC3E}">
+        <p14:creationId xmlns:p14="http://schemas.microsoft.com/office/powerpoint/2010/main" val="1615014222"/>
       </p:ext>
     </p:extLst>
   </p:cSld>
@@ -4267,8 +5257,8 @@
           </a:extLst>
         </p:spPr>
       </p:pic>
-      <mc:AlternateContent xmlns:mc="http://schemas.openxmlformats.org/markup-compatibility/2006">
-        <mc:Choice xmlns:a14="http://schemas.microsoft.com/office/drawing/2010/main" Requires="a14">
+      <mc:AlternateContent xmlns:mc="http://schemas.openxmlformats.org/markup-compatibility/2006" xmlns:a14="http://schemas.microsoft.com/office/drawing/2010/main">
+        <mc:Choice Requires="a14">
           <p:sp>
             <p:nvSpPr>
               <p:cNvPr id="4" name="TextBox 3">
@@ -4297,6 +5287,7 @@
               </a:bodyPr>
               <a:lstStyle/>
               <a:p>
+                <a:pPr/>
                 <a14:m>
                   <m:oMathPara xmlns:m="http://schemas.openxmlformats.org/officeDocument/2006/math">
                     <m:oMathParaPr>
@@ -4367,7 +5358,7 @@
             </p:txBody>
           </p:sp>
         </mc:Choice>
-        <mc:Fallback>
+        <mc:Fallback xmlns="">
           <p:sp>
             <p:nvSpPr>
               <p:cNvPr id="4" name="TextBox 3">
@@ -4526,8 +5517,8 @@
           </a:fontRef>
         </p:style>
       </p:cxnSp>
-      <mc:AlternateContent xmlns:mc="http://schemas.openxmlformats.org/markup-compatibility/2006">
-        <mc:Choice xmlns:a14="http://schemas.microsoft.com/office/drawing/2010/main" Requires="a14">
+      <mc:AlternateContent xmlns:mc="http://schemas.openxmlformats.org/markup-compatibility/2006" xmlns:a14="http://schemas.microsoft.com/office/drawing/2010/main">
+        <mc:Choice Requires="a14">
           <p:sp>
             <p:nvSpPr>
               <p:cNvPr id="11" name="TextBox 10">
@@ -4556,6 +5547,7 @@
               </a:bodyPr>
               <a:lstStyle/>
               <a:p>
+                <a:pPr/>
                 <a14:m>
                   <m:oMathPara xmlns:m="http://schemas.openxmlformats.org/officeDocument/2006/math">
                     <m:oMathParaPr>
@@ -4591,7 +5583,7 @@
             </p:txBody>
           </p:sp>
         </mc:Choice>
-        <mc:Fallback>
+        <mc:Fallback xmlns="">
           <p:sp>
             <p:nvSpPr>
               <p:cNvPr id="11" name="TextBox 10">
@@ -4666,40 +5658,12 @@
           <a:chExt cx="0" cy="0"/>
         </a:xfrm>
       </p:grpSpPr>
-      <p:sp>
-        <p:nvSpPr>
-          <p:cNvPr id="2" name="Title 1">
-            <a:extLst>
-              <a:ext uri="{FF2B5EF4-FFF2-40B4-BE49-F238E27FC236}">
-                <a16:creationId xmlns:a16="http://schemas.microsoft.com/office/drawing/2014/main" id="{3F2E82A8-F9D2-32A3-2983-60816312102D}"/>
-              </a:ext>
-            </a:extLst>
-          </p:cNvPr>
-          <p:cNvSpPr>
-            <a:spLocks noGrp="1"/>
-          </p:cNvSpPr>
-          <p:nvPr>
-            <p:ph type="title"/>
-          </p:nvPr>
-        </p:nvSpPr>
-        <p:spPr/>
-        <p:txBody>
-          <a:bodyPr/>
-          <a:lstStyle/>
-          <a:p>
-            <a:r>
-              <a:rPr lang="en-US" dirty="0"/>
-              <a:t>Unwrapped data, concatenated</a:t>
-            </a:r>
-          </a:p>
-        </p:txBody>
-      </p:sp>
       <p:pic>
         <p:nvPicPr>
-          <p:cNvPr id="3073" name="Picture 1">
-            <a:extLst>
-              <a:ext uri="{FF2B5EF4-FFF2-40B4-BE49-F238E27FC236}">
-                <a16:creationId xmlns:a16="http://schemas.microsoft.com/office/drawing/2014/main" id="{43FA0C10-E263-6CCB-67A7-A435F4607F65}"/>
+          <p:cNvPr id="1026" name="Picture 2">
+            <a:extLst>
+              <a:ext uri="{FF2B5EF4-FFF2-40B4-BE49-F238E27FC236}">
+                <a16:creationId xmlns:a16="http://schemas.microsoft.com/office/drawing/2014/main" id="{AA68F1E6-9396-BBF2-BE08-7650A5B7C08B}"/>
               </a:ext>
             </a:extLst>
           </p:cNvPr>
@@ -4723,8 +5687,8 @@
         </p:blipFill>
         <p:spPr bwMode="auto">
           <a:xfrm>
-            <a:off x="678729" y="1621410"/>
-            <a:ext cx="5553075" cy="4333875"/>
+            <a:off x="6389435" y="1865750"/>
+            <a:ext cx="5524500" cy="4114800"/>
           </a:xfrm>
           <a:prstGeom prst="rect">
             <a:avLst/>
@@ -4741,12 +5705,40 @@
           </a:extLst>
         </p:spPr>
       </p:pic>
+      <p:sp>
+        <p:nvSpPr>
+          <p:cNvPr id="2" name="Title 1">
+            <a:extLst>
+              <a:ext uri="{FF2B5EF4-FFF2-40B4-BE49-F238E27FC236}">
+                <a16:creationId xmlns:a16="http://schemas.microsoft.com/office/drawing/2014/main" id="{3F2E82A8-F9D2-32A3-2983-60816312102D}"/>
+              </a:ext>
+            </a:extLst>
+          </p:cNvPr>
+          <p:cNvSpPr>
+            <a:spLocks noGrp="1"/>
+          </p:cNvSpPr>
+          <p:nvPr>
+            <p:ph type="title"/>
+          </p:nvPr>
+        </p:nvSpPr>
+        <p:spPr/>
+        <p:txBody>
+          <a:bodyPr/>
+          <a:lstStyle/>
+          <a:p>
+            <a:r>
+              <a:rPr lang="en-US" dirty="0"/>
+              <a:t>Unwrapped data, concatenated</a:t>
+            </a:r>
+          </a:p>
+        </p:txBody>
+      </p:sp>
       <p:pic>
         <p:nvPicPr>
-          <p:cNvPr id="3074" name="Picture 2">
-            <a:extLst>
-              <a:ext uri="{FF2B5EF4-FFF2-40B4-BE49-F238E27FC236}">
-                <a16:creationId xmlns:a16="http://schemas.microsoft.com/office/drawing/2014/main" id="{F964EA72-6579-B881-FAB9-DA5A96C4AD88}"/>
+          <p:cNvPr id="3073" name="Picture 1">
+            <a:extLst>
+              <a:ext uri="{FF2B5EF4-FFF2-40B4-BE49-F238E27FC236}">
+                <a16:creationId xmlns:a16="http://schemas.microsoft.com/office/drawing/2014/main" id="{43FA0C10-E263-6CCB-67A7-A435F4607F65}"/>
               </a:ext>
             </a:extLst>
           </p:cNvPr>
@@ -4770,8 +5762,8 @@
         </p:blipFill>
         <p:spPr bwMode="auto">
           <a:xfrm>
-            <a:off x="6419654" y="1821434"/>
-            <a:ext cx="5343525" cy="3933825"/>
+            <a:off x="678729" y="1621410"/>
+            <a:ext cx="5553075" cy="4333875"/>
           </a:xfrm>
           <a:prstGeom prst="rect">
             <a:avLst/>
@@ -4802,7 +5794,7 @@
         </p:nvSpPr>
         <p:spPr>
           <a:xfrm>
-            <a:off x="8795208" y="4135097"/>
+            <a:off x="8077029" y="3946679"/>
             <a:ext cx="1074656" cy="523220"/>
           </a:xfrm>
           <a:prstGeom prst="rect">
@@ -4841,7 +5833,7 @@
         </p:nvSpPr>
         <p:spPr>
           <a:xfrm>
-            <a:off x="8403259" y="3038156"/>
+            <a:off x="7584275" y="2461293"/>
             <a:ext cx="2013359" cy="523220"/>
           </a:xfrm>
           <a:prstGeom prst="rect">
@@ -4897,6 +5889,76 @@
             <a:r>
               <a:rPr lang="en-US" dirty="0"/>
               <a:t>Concatenate imaginary on top of real to make a function that can be fit with both real and imaginary</a:t>
+            </a:r>
+          </a:p>
+        </p:txBody>
+      </p:sp>
+      <p:sp>
+        <p:nvSpPr>
+          <p:cNvPr id="3" name="TextBox 2">
+            <a:extLst>
+              <a:ext uri="{FF2B5EF4-FFF2-40B4-BE49-F238E27FC236}">
+                <a16:creationId xmlns:a16="http://schemas.microsoft.com/office/drawing/2014/main" id="{E383F400-A01E-9951-986C-2EFFEA6D7BB9}"/>
+              </a:ext>
+            </a:extLst>
+          </p:cNvPr>
+          <p:cNvSpPr txBox="1"/>
+          <p:nvPr/>
+        </p:nvSpPr>
+        <p:spPr>
+          <a:xfrm rot="16200000">
+            <a:off x="9258438" y="4828116"/>
+            <a:ext cx="678391" cy="369332"/>
+          </a:xfrm>
+          <a:prstGeom prst="rect">
+            <a:avLst/>
+          </a:prstGeom>
+          <a:noFill/>
+        </p:spPr>
+        <p:txBody>
+          <a:bodyPr wrap="none" rtlCol="0">
+            <a:spAutoFit/>
+          </a:bodyPr>
+          <a:lstStyle/>
+          <a:p>
+            <a:r>
+              <a:rPr lang="en-US" dirty="0"/>
+              <a:t>1100</a:t>
+            </a:r>
+          </a:p>
+        </p:txBody>
+      </p:sp>
+      <p:sp>
+        <p:nvSpPr>
+          <p:cNvPr id="7" name="TextBox 6">
+            <a:extLst>
+              <a:ext uri="{FF2B5EF4-FFF2-40B4-BE49-F238E27FC236}">
+                <a16:creationId xmlns:a16="http://schemas.microsoft.com/office/drawing/2014/main" id="{8959BB9D-A38B-0DC2-A046-02E40659157C}"/>
+              </a:ext>
+            </a:extLst>
+          </p:cNvPr>
+          <p:cNvSpPr txBox="1"/>
+          <p:nvPr/>
+        </p:nvSpPr>
+        <p:spPr>
+          <a:xfrm rot="16200000">
+            <a:off x="9731973" y="3762012"/>
+            <a:ext cx="678391" cy="369332"/>
+          </a:xfrm>
+          <a:prstGeom prst="rect">
+            <a:avLst/>
+          </a:prstGeom>
+          <a:noFill/>
+        </p:spPr>
+        <p:txBody>
+          <a:bodyPr wrap="none" rtlCol="0">
+            <a:spAutoFit/>
+          </a:bodyPr>
+          <a:lstStyle/>
+          <a:p>
+            <a:r>
+              <a:rPr lang="en-US" dirty="0"/>
+              <a:t>1300</a:t>
             </a:r>
           </a:p>
         </p:txBody>
@@ -5111,100 +6173,6 @@
           </a:p>
         </p:txBody>
       </p:sp>
-      <p:pic>
-        <p:nvPicPr>
-          <p:cNvPr id="5124" name="Picture 4">
-            <a:extLst>
-              <a:ext uri="{FF2B5EF4-FFF2-40B4-BE49-F238E27FC236}">
-                <a16:creationId xmlns:a16="http://schemas.microsoft.com/office/drawing/2014/main" id="{16E26746-F127-6693-B1C6-75F4D284C857}"/>
-              </a:ext>
-            </a:extLst>
-          </p:cNvPr>
-          <p:cNvPicPr>
-            <a:picLocks noChangeAspect="1" noChangeArrowheads="1"/>
-          </p:cNvPicPr>
-          <p:nvPr/>
-        </p:nvPicPr>
-        <p:blipFill>
-          <a:blip r:embed="rId2">
-            <a:extLst>
-              <a:ext uri="{28A0092B-C50C-407E-A947-70E740481C1C}">
-                <a14:useLocalDpi xmlns:a14="http://schemas.microsoft.com/office/drawing/2010/main" val="0"/>
-              </a:ext>
-            </a:extLst>
-          </a:blip>
-          <a:srcRect/>
-          <a:stretch>
-            <a:fillRect/>
-          </a:stretch>
-        </p:blipFill>
-        <p:spPr bwMode="auto">
-          <a:xfrm>
-            <a:off x="282803" y="1959596"/>
-            <a:ext cx="5438775" cy="4314825"/>
-          </a:xfrm>
-          <a:prstGeom prst="rect">
-            <a:avLst/>
-          </a:prstGeom>
-          <a:noFill/>
-          <a:extLst>
-            <a:ext uri="{909E8E84-426E-40DD-AFC4-6F175D3DCCD1}">
-              <a14:hiddenFill xmlns:a14="http://schemas.microsoft.com/office/drawing/2010/main">
-                <a:solidFill>
-                  <a:srgbClr val="FFFFFF"/>
-                </a:solidFill>
-              </a14:hiddenFill>
-            </a:ext>
-          </a:extLst>
-        </p:spPr>
-      </p:pic>
-      <p:pic>
-        <p:nvPicPr>
-          <p:cNvPr id="5125" name="Picture 5">
-            <a:extLst>
-              <a:ext uri="{FF2B5EF4-FFF2-40B4-BE49-F238E27FC236}">
-                <a16:creationId xmlns:a16="http://schemas.microsoft.com/office/drawing/2014/main" id="{8BCDBE60-4568-C909-9A2F-BCE3740BA4E8}"/>
-              </a:ext>
-            </a:extLst>
-          </p:cNvPr>
-          <p:cNvPicPr>
-            <a:picLocks noChangeAspect="1" noChangeArrowheads="1"/>
-          </p:cNvPicPr>
-          <p:nvPr/>
-        </p:nvPicPr>
-        <p:blipFill>
-          <a:blip r:embed="rId3">
-            <a:extLst>
-              <a:ext uri="{28A0092B-C50C-407E-A947-70E740481C1C}">
-                <a14:useLocalDpi xmlns:a14="http://schemas.microsoft.com/office/drawing/2010/main" val="0"/>
-              </a:ext>
-            </a:extLst>
-          </a:blip>
-          <a:srcRect/>
-          <a:stretch>
-            <a:fillRect/>
-          </a:stretch>
-        </p:blipFill>
-        <p:spPr bwMode="auto">
-          <a:xfrm>
-            <a:off x="6470424" y="2102471"/>
-            <a:ext cx="5514975" cy="4171950"/>
-          </a:xfrm>
-          <a:prstGeom prst="rect">
-            <a:avLst/>
-          </a:prstGeom>
-          <a:noFill/>
-          <a:extLst>
-            <a:ext uri="{909E8E84-426E-40DD-AFC4-6F175D3DCCD1}">
-              <a14:hiddenFill xmlns:a14="http://schemas.microsoft.com/office/drawing/2010/main">
-                <a:solidFill>
-                  <a:srgbClr val="FFFFFF"/>
-                </a:solidFill>
-              </a14:hiddenFill>
-            </a:ext>
-          </a:extLst>
-        </p:spPr>
-      </p:pic>
       <p:sp>
         <p:nvSpPr>
           <p:cNvPr id="4" name="Arrow: Right 3">
@@ -5251,6 +6219,100 @@
           </a:p>
         </p:txBody>
       </p:sp>
+      <p:pic>
+        <p:nvPicPr>
+          <p:cNvPr id="2050" name="Picture 2">
+            <a:extLst>
+              <a:ext uri="{FF2B5EF4-FFF2-40B4-BE49-F238E27FC236}">
+                <a16:creationId xmlns:a16="http://schemas.microsoft.com/office/drawing/2014/main" id="{474146F9-D22D-C8EF-26B1-E9FCB3A6CBDA}"/>
+              </a:ext>
+            </a:extLst>
+          </p:cNvPr>
+          <p:cNvPicPr>
+            <a:picLocks noChangeAspect="1" noChangeArrowheads="1"/>
+          </p:cNvPicPr>
+          <p:nvPr/>
+        </p:nvPicPr>
+        <p:blipFill>
+          <a:blip r:embed="rId2">
+            <a:extLst>
+              <a:ext uri="{28A0092B-C50C-407E-A947-70E740481C1C}">
+                <a14:useLocalDpi xmlns:a14="http://schemas.microsoft.com/office/drawing/2010/main" val="0"/>
+              </a:ext>
+            </a:extLst>
+          </a:blip>
+          <a:srcRect/>
+          <a:stretch>
+            <a:fillRect/>
+          </a:stretch>
+        </p:blipFill>
+        <p:spPr bwMode="auto">
+          <a:xfrm>
+            <a:off x="182498" y="1772828"/>
+            <a:ext cx="5505450" cy="4314825"/>
+          </a:xfrm>
+          <a:prstGeom prst="rect">
+            <a:avLst/>
+          </a:prstGeom>
+          <a:noFill/>
+          <a:extLst>
+            <a:ext uri="{909E8E84-426E-40DD-AFC4-6F175D3DCCD1}">
+              <a14:hiddenFill xmlns:a14="http://schemas.microsoft.com/office/drawing/2010/main">
+                <a:solidFill>
+                  <a:srgbClr val="FFFFFF"/>
+                </a:solidFill>
+              </a14:hiddenFill>
+            </a:ext>
+          </a:extLst>
+        </p:spPr>
+      </p:pic>
+      <p:pic>
+        <p:nvPicPr>
+          <p:cNvPr id="2051" name="Picture 3">
+            <a:extLst>
+              <a:ext uri="{FF2B5EF4-FFF2-40B4-BE49-F238E27FC236}">
+                <a16:creationId xmlns:a16="http://schemas.microsoft.com/office/drawing/2014/main" id="{D815A586-B830-5ED5-B01F-9E2A2637B719}"/>
+              </a:ext>
+            </a:extLst>
+          </p:cNvPr>
+          <p:cNvPicPr>
+            <a:picLocks noChangeAspect="1" noChangeArrowheads="1"/>
+          </p:cNvPicPr>
+          <p:nvPr/>
+        </p:nvPicPr>
+        <p:blipFill>
+          <a:blip r:embed="rId3">
+            <a:extLst>
+              <a:ext uri="{28A0092B-C50C-407E-A947-70E740481C1C}">
+                <a14:useLocalDpi xmlns:a14="http://schemas.microsoft.com/office/drawing/2010/main" val="0"/>
+              </a:ext>
+            </a:extLst>
+          </a:blip>
+          <a:srcRect/>
+          <a:stretch>
+            <a:fillRect/>
+          </a:stretch>
+        </p:blipFill>
+        <p:spPr bwMode="auto">
+          <a:xfrm>
+            <a:off x="6619875" y="1915703"/>
+            <a:ext cx="5572125" cy="4171950"/>
+          </a:xfrm>
+          <a:prstGeom prst="rect">
+            <a:avLst/>
+          </a:prstGeom>
+          <a:noFill/>
+          <a:extLst>
+            <a:ext uri="{909E8E84-426E-40DD-AFC4-6F175D3DCCD1}">
+              <a14:hiddenFill xmlns:a14="http://schemas.microsoft.com/office/drawing/2010/main">
+                <a:solidFill>
+                  <a:srgbClr val="FFFFFF"/>
+                </a:solidFill>
+              </a14:hiddenFill>
+            </a:ext>
+          </a:extLst>
+        </p:spPr>
+      </p:pic>
     </p:spTree>
     <p:extLst>
       <p:ext uri="{BB962C8B-B14F-4D97-AF65-F5344CB8AC3E}">
@@ -5311,10 +6373,10 @@
       </p:sp>
       <p:pic>
         <p:nvPicPr>
-          <p:cNvPr id="6147" name="Picture 3">
-            <a:extLst>
-              <a:ext uri="{FF2B5EF4-FFF2-40B4-BE49-F238E27FC236}">
-                <a16:creationId xmlns:a16="http://schemas.microsoft.com/office/drawing/2014/main" id="{8A04EB95-2A73-9A51-9CB4-17EEF463EBEE}"/>
+          <p:cNvPr id="3073" name="Picture 1">
+            <a:extLst>
+              <a:ext uri="{FF2B5EF4-FFF2-40B4-BE49-F238E27FC236}">
+                <a16:creationId xmlns:a16="http://schemas.microsoft.com/office/drawing/2014/main" id="{6E0E09CC-A7E6-6F21-EB76-E119C634B866}"/>
               </a:ext>
             </a:extLst>
           </p:cNvPr>
@@ -5338,8 +6400,8 @@
         </p:blipFill>
         <p:spPr bwMode="auto">
           <a:xfrm>
-            <a:off x="0" y="1448901"/>
-            <a:ext cx="5191125" cy="5191125"/>
+            <a:off x="452762" y="1448446"/>
+            <a:ext cx="5257800" cy="5000625"/>
           </a:xfrm>
           <a:prstGeom prst="rect">
             <a:avLst/>
@@ -5358,10 +6420,10 @@
       </p:pic>
       <p:pic>
         <p:nvPicPr>
-          <p:cNvPr id="6148" name="Picture 4">
-            <a:extLst>
-              <a:ext uri="{FF2B5EF4-FFF2-40B4-BE49-F238E27FC236}">
-                <a16:creationId xmlns:a16="http://schemas.microsoft.com/office/drawing/2014/main" id="{D12478FC-0C47-1145-1B04-66093EAE67E2}"/>
+          <p:cNvPr id="3074" name="Picture 2">
+            <a:extLst>
+              <a:ext uri="{FF2B5EF4-FFF2-40B4-BE49-F238E27FC236}">
+                <a16:creationId xmlns:a16="http://schemas.microsoft.com/office/drawing/2014/main" id="{9C9FAE23-1F60-6F07-B32A-76F1BE1EFE2E}"/>
               </a:ext>
             </a:extLst>
           </p:cNvPr>
@@ -5385,8 +6447,8 @@
         </p:blipFill>
         <p:spPr bwMode="auto">
           <a:xfrm>
-            <a:off x="6248400" y="1639401"/>
-            <a:ext cx="5105400" cy="5000625"/>
+            <a:off x="6481439" y="1448447"/>
+            <a:ext cx="5257800" cy="5000625"/>
           </a:xfrm>
           <a:prstGeom prst="rect">
             <a:avLst/>
@@ -5461,55 +6523,8 @@
           </a:p>
         </p:txBody>
       </p:sp>
-      <p:pic>
-        <p:nvPicPr>
-          <p:cNvPr id="7169" name="Picture 1">
-            <a:extLst>
-              <a:ext uri="{FF2B5EF4-FFF2-40B4-BE49-F238E27FC236}">
-                <a16:creationId xmlns:a16="http://schemas.microsoft.com/office/drawing/2014/main" id="{9727DC05-B2F3-3150-A080-E6B7BE4B5FBF}"/>
-              </a:ext>
-            </a:extLst>
-          </p:cNvPr>
-          <p:cNvPicPr>
-            <a:picLocks noChangeAspect="1" noChangeArrowheads="1"/>
-          </p:cNvPicPr>
-          <p:nvPr/>
-        </p:nvPicPr>
-        <p:blipFill>
-          <a:blip r:embed="rId2">
-            <a:extLst>
-              <a:ext uri="{28A0092B-C50C-407E-A947-70E740481C1C}">
-                <a14:useLocalDpi xmlns:a14="http://schemas.microsoft.com/office/drawing/2010/main" val="0"/>
-              </a:ext>
-            </a:extLst>
-          </a:blip>
-          <a:srcRect/>
-          <a:stretch>
-            <a:fillRect/>
-          </a:stretch>
-        </p:blipFill>
-        <p:spPr bwMode="auto">
-          <a:xfrm>
-            <a:off x="800100" y="1690688"/>
-            <a:ext cx="5295900" cy="5000625"/>
-          </a:xfrm>
-          <a:prstGeom prst="rect">
-            <a:avLst/>
-          </a:prstGeom>
-          <a:noFill/>
-          <a:extLst>
-            <a:ext uri="{909E8E84-426E-40DD-AFC4-6F175D3DCCD1}">
-              <a14:hiddenFill xmlns:a14="http://schemas.microsoft.com/office/drawing/2010/main">
-                <a:solidFill>
-                  <a:srgbClr val="FFFFFF"/>
-                </a:solidFill>
-              </a14:hiddenFill>
-            </a:ext>
-          </a:extLst>
-        </p:spPr>
-      </p:pic>
-      <mc:AlternateContent xmlns:mc="http://schemas.openxmlformats.org/markup-compatibility/2006">
-        <mc:Choice xmlns:a14="http://schemas.microsoft.com/office/drawing/2010/main" Requires="a14">
+      <mc:AlternateContent xmlns:mc="http://schemas.openxmlformats.org/markup-compatibility/2006" xmlns:a14="http://schemas.microsoft.com/office/drawing/2010/main">
+        <mc:Choice Requires="a14">
           <p:sp>
             <p:nvSpPr>
               <p:cNvPr id="6" name="TextBox 5">
@@ -5538,6 +6553,7 @@
               </a:bodyPr>
               <a:lstStyle/>
               <a:p>
+                <a:pPr/>
                 <a14:m>
                   <m:oMathPara xmlns:m="http://schemas.openxmlformats.org/officeDocument/2006/math">
                     <m:oMathParaPr>
@@ -5608,7 +6624,7 @@
             </p:txBody>
           </p:sp>
         </mc:Choice>
-        <mc:Fallback>
+        <mc:Fallback xmlns="">
           <p:sp>
             <p:nvSpPr>
               <p:cNvPr id="6" name="TextBox 5">
@@ -5653,6 +6669,53 @@
           </p:sp>
         </mc:Fallback>
       </mc:AlternateContent>
+      <p:pic>
+        <p:nvPicPr>
+          <p:cNvPr id="4097" name="Picture 1">
+            <a:extLst>
+              <a:ext uri="{FF2B5EF4-FFF2-40B4-BE49-F238E27FC236}">
+                <a16:creationId xmlns:a16="http://schemas.microsoft.com/office/drawing/2014/main" id="{D1B9FA85-DB7E-6F6D-3B33-C1389198DEAC}"/>
+              </a:ext>
+            </a:extLst>
+          </p:cNvPr>
+          <p:cNvPicPr>
+            <a:picLocks noChangeAspect="1" noChangeArrowheads="1"/>
+          </p:cNvPicPr>
+          <p:nvPr/>
+        </p:nvPicPr>
+        <p:blipFill>
+          <a:blip r:embed="rId4">
+            <a:extLst>
+              <a:ext uri="{28A0092B-C50C-407E-A947-70E740481C1C}">
+                <a14:useLocalDpi xmlns:a14="http://schemas.microsoft.com/office/drawing/2010/main" val="0"/>
+              </a:ext>
+            </a:extLst>
+          </a:blip>
+          <a:srcRect/>
+          <a:stretch>
+            <a:fillRect/>
+          </a:stretch>
+        </p:blipFill>
+        <p:spPr bwMode="auto">
+          <a:xfrm>
+            <a:off x="1129085" y="1796996"/>
+            <a:ext cx="5257800" cy="5000625"/>
+          </a:xfrm>
+          <a:prstGeom prst="rect">
+            <a:avLst/>
+          </a:prstGeom>
+          <a:noFill/>
+          <a:extLst>
+            <a:ext uri="{909E8E84-426E-40DD-AFC4-6F175D3DCCD1}">
+              <a14:hiddenFill xmlns:a14="http://schemas.microsoft.com/office/drawing/2010/main">
+                <a:solidFill>
+                  <a:srgbClr val="FFFFFF"/>
+                </a:solidFill>
+              </a14:hiddenFill>
+            </a:ext>
+          </a:extLst>
+        </p:spPr>
+      </p:pic>
     </p:spTree>
     <p:extLst>
       <p:ext uri="{BB962C8B-B14F-4D97-AF65-F5344CB8AC3E}">

</xml_diff>